<commit_message>
Aktualizacja ostatniego slajdu prezentacji
</commit_message>
<xml_diff>
--- a/Zarządzanie stanem Anna Leś.pptx
+++ b/Zarządzanie stanem Anna Leś.pptx
@@ -27553,8 +27553,8 @@
         </p:nvSpPr>
         <p:spPr>
           <a:xfrm>
-            <a:off x="453142" y="2659366"/>
-            <a:ext cx="6028339" cy="2942987"/>
+            <a:off x="453142" y="2659367"/>
+            <a:ext cx="6028339" cy="2282888"/>
           </a:xfrm>
         </p:spPr>
         <p:txBody>
@@ -27578,38 +27578,13 @@
               <a:t> Toolkit skalowalnością.</a:t>
             </a:r>
           </a:p>
-        </p:txBody>
-      </p:sp>
-      <p:sp>
-        <p:nvSpPr>
-          <p:cNvPr id="15" name="Data — symbol zastępczy 14">
-            <a:extLst>
-              <a:ext uri="{FF2B5EF4-FFF2-40B4-BE49-F238E27FC236}">
-                <a16:creationId xmlns:a16="http://schemas.microsoft.com/office/drawing/2014/main" id="{F0B1D64A-4BCA-40E9-8D9F-56E3FA5A734D}"/>
-              </a:ext>
-            </a:extLst>
-          </p:cNvPr>
-          <p:cNvSpPr>
-            <a:spLocks noGrp="1"/>
-          </p:cNvSpPr>
-          <p:nvPr>
-            <p:ph type="dt" sz="half" idx="10"/>
-          </p:nvPr>
-        </p:nvSpPr>
-        <p:spPr>
-          <a:xfrm>
-            <a:off x="457200" y="6324600"/>
-            <a:ext cx="2560220" cy="365125"/>
-          </a:xfrm>
-        </p:spPr>
-        <p:txBody>
-          <a:bodyPr rtlCol="0"/>
-          <a:lstStyle/>
           <a:p>
-            <a:pPr rtl="0"/>
-            <a:r>
-              <a:rPr lang="pl-PL"/>
-              <a:t>20XX-02-02</a:t>
+            <a:endParaRPr lang="pl-PL" sz="2000" dirty="0"/>
+          </a:p>
+          <a:p>
+            <a:r>
+              <a:rPr lang="pl-PL" sz="2000" dirty="0"/>
+              <a:t>https://github.com/annales050990/prezentacja.git</a:t>
             </a:r>
           </a:p>
         </p:txBody>
@@ -27744,8 +27719,8 @@
           <a:p>
             <a:pPr rtl="0"/>
             <a:r>
-              <a:rPr lang="pl-PL"/>
-              <a:t>TYTUŁ PREZENTACJI</a:t>
+              <a:rPr lang="pl-PL" dirty="0"/>
+              <a:t>Zarządzanie stanem</a:t>
             </a:r>
           </a:p>
         </p:txBody>
@@ -27844,9 +27819,13 @@
           <a:p>
             <a:pPr rtl="0"/>
             <a:r>
-              <a:rPr lang="pl-PL"/>
-              <a:t>Dziękujemy</a:t>
-            </a:r>
+              <a:rPr lang="pl-PL" dirty="0"/>
+              <a:t>Dziękuję za uwagę</a:t>
+            </a:r>
+            <a:br>
+              <a:rPr lang="pl-PL" dirty="0"/>
+            </a:br>
+            <a:endParaRPr lang="pl-PL" dirty="0"/>
           </a:p>
         </p:txBody>
       </p:sp>
@@ -27878,56 +27857,15 @@
           <a:p>
             <a:pPr rtl="0"/>
             <a:r>
-              <a:rPr lang="pl-PL"/>
-              <a:t>Imię i nazwisko osoby prowadzącej</a:t>
+              <a:rPr lang="pl-PL" dirty="0"/>
+              <a:t>Anna Leś</a:t>
             </a:r>
           </a:p>
           <a:p>
             <a:pPr rtl="0"/>
             <a:r>
-              <a:rPr lang="pl-PL"/>
-              <a:t>Adres e-mail</a:t>
-            </a:r>
-          </a:p>
-          <a:p>
-            <a:pPr rtl="0"/>
-            <a:r>
-              <a:rPr lang="pl-PL"/>
-              <a:t>Witryna internetowa</a:t>
-            </a:r>
-          </a:p>
-        </p:txBody>
-      </p:sp>
-      <p:sp>
-        <p:nvSpPr>
-          <p:cNvPr id="5" name="Data — symbol zastępczy 4">
-            <a:extLst>
-              <a:ext uri="{FF2B5EF4-FFF2-40B4-BE49-F238E27FC236}">
-                <a16:creationId xmlns:a16="http://schemas.microsoft.com/office/drawing/2014/main" id="{19D4122A-7E05-408B-9546-A9E085CE8124}"/>
-              </a:ext>
-            </a:extLst>
-          </p:cNvPr>
-          <p:cNvSpPr>
-            <a:spLocks noGrp="1"/>
-          </p:cNvSpPr>
-          <p:nvPr>
-            <p:ph type="dt" sz="half" idx="10"/>
-          </p:nvPr>
-        </p:nvSpPr>
-        <p:spPr>
-          <a:xfrm>
-            <a:off x="457200" y="6324600"/>
-            <a:ext cx="2560220" cy="365125"/>
-          </a:xfrm>
-        </p:spPr>
-        <p:txBody>
-          <a:bodyPr rtlCol="0"/>
-          <a:lstStyle/>
-          <a:p>
-            <a:pPr rtl="0"/>
-            <a:r>
-              <a:rPr lang="pl-PL"/>
-              <a:t>20XX-02-02</a:t>
+              <a:rPr lang="pl-PL" dirty="0"/>
+              <a:t>annales90@wp.pl</a:t>
             </a:r>
           </a:p>
         </p:txBody>
@@ -27994,8 +27932,8 @@
           <a:p>
             <a:pPr rtl="0"/>
             <a:r>
-              <a:rPr lang="pl-PL"/>
-              <a:t>TYTUŁ PREZENTACJI</a:t>
+              <a:rPr lang="pl-PL" dirty="0"/>
+              <a:t>Zarządzanie stanem</a:t>
             </a:r>
           </a:p>
         </p:txBody>
@@ -33344,6 +33282,15 @@
 </file>
 
 <file path=customXml/item1.xml><?xml version="1.0" encoding="utf-8"?>
+<?mso-contentType ?>
+<FormTemplates xmlns="http://schemas.microsoft.com/sharepoint/v3/contenttype/forms">
+  <Display>DocumentLibraryForm</Display>
+  <Edit>DocumentLibraryForm</Edit>
+  <New>DocumentLibraryForm</New>
+</FormTemplates>
+</file>
+
+<file path=customXml/item2.xml><?xml version="1.0" encoding="utf-8"?>
 <p:properties xmlns:p="http://schemas.microsoft.com/office/2006/metadata/properties" xmlns:xsi="http://www.w3.org/2001/XMLSchema-instance" xmlns:pc="http://schemas.microsoft.com/office/infopath/2007/PartnerControls">
   <documentManagement>
     <_ip_UnifiedCompliancePolicyUIAction xmlns="http://schemas.microsoft.com/sharepoint/v3" xsi:nil="true"/>
@@ -33360,15 +33307,6 @@
     <MediaServiceKeyPoints xmlns="71af3243-3dd4-4a8d-8c0d-dd76da1f02a5" xsi:nil="true"/>
   </documentManagement>
 </p:properties>
-</file>
-
-<file path=customXml/item2.xml><?xml version="1.0" encoding="utf-8"?>
-<?mso-contentType ?>
-<FormTemplates xmlns="http://schemas.microsoft.com/sharepoint/v3/contenttype/forms">
-  <Display>DocumentLibraryForm</Display>
-  <Edit>DocumentLibraryForm</Edit>
-  <New>DocumentLibraryForm</New>
-</FormTemplates>
 </file>
 
 <file path=customXml/item3.xml><?xml version="1.0" encoding="utf-8"?>
@@ -33648,6 +33586,14 @@
 </file>
 
 <file path=customXml/itemProps1.xml><?xml version="1.0" encoding="utf-8"?>
+<ds:datastoreItem xmlns:ds="http://schemas.openxmlformats.org/officeDocument/2006/customXml" ds:itemID="{F49FD94B-CF2B-4485-954E-6805E96E51FA}">
+  <ds:schemaRefs>
+    <ds:schemaRef ds:uri="http://schemas.microsoft.com/sharepoint/v3/contenttype/forms"/>
+  </ds:schemaRefs>
+</ds:datastoreItem>
+</file>
+
+<file path=customXml/itemProps2.xml><?xml version="1.0" encoding="utf-8"?>
 <ds:datastoreItem xmlns:ds="http://schemas.openxmlformats.org/officeDocument/2006/customXml" ds:itemID="{538316A4-DB9D-4B40-83D1-0433996D54B0}">
   <ds:schemaRefs>
     <ds:schemaRef ds:uri="http://schemas.microsoft.com/office/2006/metadata/properties"/>
@@ -33655,14 +33601,6 @@
     <ds:schemaRef ds:uri="http://schemas.microsoft.com/sharepoint/v3"/>
     <ds:schemaRef ds:uri="71af3243-3dd4-4a8d-8c0d-dd76da1f02a5"/>
     <ds:schemaRef ds:uri="230e9df3-be65-4c73-a93b-d1236ebd677e"/>
-  </ds:schemaRefs>
-</ds:datastoreItem>
-</file>
-
-<file path=customXml/itemProps2.xml><?xml version="1.0" encoding="utf-8"?>
-<ds:datastoreItem xmlns:ds="http://schemas.openxmlformats.org/officeDocument/2006/customXml" ds:itemID="{F49FD94B-CF2B-4485-954E-6805E96E51FA}">
-  <ds:schemaRefs>
-    <ds:schemaRef ds:uri="http://schemas.microsoft.com/sharepoint/v3/contenttype/forms"/>
   </ds:schemaRefs>
 </ds:datastoreItem>
 </file>

</xml_diff>